<commit_message>
IF --> NLP template
</commit_message>
<xml_diff>
--- a/homeworks/project/poster-template.pptx
+++ b/homeworks/project/poster-template.pptx
@@ -243,7 +243,7 @@
           <a:p>
             <a:fld id="{BEA761C5-5839-4D3D-A874-271BB1853741}" type="datetimeFigureOut">
               <a:rPr lang="en-US" smtClean="0"/>
-              <a:t>12/2/2025</a:t>
+              <a:t>5/3/2026</a:t>
             </a:fld>
             <a:endParaRPr lang="en-US"/>
           </a:p>
@@ -413,7 +413,7 @@
           <a:p>
             <a:fld id="{BEA761C5-5839-4D3D-A874-271BB1853741}" type="datetimeFigureOut">
               <a:rPr lang="en-US" smtClean="0"/>
-              <a:t>12/2/2025</a:t>
+              <a:t>5/3/2026</a:t>
             </a:fld>
             <a:endParaRPr lang="en-US"/>
           </a:p>
@@ -593,7 +593,7 @@
           <a:p>
             <a:fld id="{BEA761C5-5839-4D3D-A874-271BB1853741}" type="datetimeFigureOut">
               <a:rPr lang="en-US" smtClean="0"/>
-              <a:t>12/2/2025</a:t>
+              <a:t>5/3/2026</a:t>
             </a:fld>
             <a:endParaRPr lang="en-US"/>
           </a:p>
@@ -763,7 +763,7 @@
           <a:p>
             <a:fld id="{BEA761C5-5839-4D3D-A874-271BB1853741}" type="datetimeFigureOut">
               <a:rPr lang="en-US" smtClean="0"/>
-              <a:t>12/2/2025</a:t>
+              <a:t>5/3/2026</a:t>
             </a:fld>
             <a:endParaRPr lang="en-US"/>
           </a:p>
@@ -1007,7 +1007,7 @@
           <a:p>
             <a:fld id="{BEA761C5-5839-4D3D-A874-271BB1853741}" type="datetimeFigureOut">
               <a:rPr lang="en-US" smtClean="0"/>
-              <a:t>12/2/2025</a:t>
+              <a:t>5/3/2026</a:t>
             </a:fld>
             <a:endParaRPr lang="en-US"/>
           </a:p>
@@ -1239,7 +1239,7 @@
           <a:p>
             <a:fld id="{BEA761C5-5839-4D3D-A874-271BB1853741}" type="datetimeFigureOut">
               <a:rPr lang="en-US" smtClean="0"/>
-              <a:t>12/2/2025</a:t>
+              <a:t>5/3/2026</a:t>
             </a:fld>
             <a:endParaRPr lang="en-US"/>
           </a:p>
@@ -1606,7 +1606,7 @@
           <a:p>
             <a:fld id="{BEA761C5-5839-4D3D-A874-271BB1853741}" type="datetimeFigureOut">
               <a:rPr lang="en-US" smtClean="0"/>
-              <a:t>12/2/2025</a:t>
+              <a:t>5/3/2026</a:t>
             </a:fld>
             <a:endParaRPr lang="en-US"/>
           </a:p>
@@ -1724,7 +1724,7 @@
           <a:p>
             <a:fld id="{BEA761C5-5839-4D3D-A874-271BB1853741}" type="datetimeFigureOut">
               <a:rPr lang="en-US" smtClean="0"/>
-              <a:t>12/2/2025</a:t>
+              <a:t>5/3/2026</a:t>
             </a:fld>
             <a:endParaRPr lang="en-US"/>
           </a:p>
@@ -1819,7 +1819,7 @@
           <a:p>
             <a:fld id="{BEA761C5-5839-4D3D-A874-271BB1853741}" type="datetimeFigureOut">
               <a:rPr lang="en-US" smtClean="0"/>
-              <a:t>12/2/2025</a:t>
+              <a:t>5/3/2026</a:t>
             </a:fld>
             <a:endParaRPr lang="en-US"/>
           </a:p>
@@ -2096,7 +2096,7 @@
           <a:p>
             <a:fld id="{BEA761C5-5839-4D3D-A874-271BB1853741}" type="datetimeFigureOut">
               <a:rPr lang="en-US" smtClean="0"/>
-              <a:t>12/2/2025</a:t>
+              <a:t>5/3/2026</a:t>
             </a:fld>
             <a:endParaRPr lang="en-US"/>
           </a:p>
@@ -2353,7 +2353,7 @@
           <a:p>
             <a:fld id="{BEA761C5-5839-4D3D-A874-271BB1853741}" type="datetimeFigureOut">
               <a:rPr lang="en-US" smtClean="0"/>
-              <a:t>12/2/2025</a:t>
+              <a:t>5/3/2026</a:t>
             </a:fld>
             <a:endParaRPr lang="en-US"/>
           </a:p>
@@ -2566,7 +2566,7 @@
           <a:p>
             <a:fld id="{BEA761C5-5839-4D3D-A874-271BB1853741}" type="datetimeFigureOut">
               <a:rPr lang="en-US" smtClean="0"/>
-              <a:t>12/2/2025</a:t>
+              <a:t>5/3/2026</a:t>
             </a:fld>
             <a:endParaRPr lang="en-US"/>
           </a:p>
@@ -4056,10 +4056,10 @@
             <p:nvPr/>
           </p:nvPicPr>
           <p:blipFill>
-            <a:blip r:embed="rId3">
+            <a:blip>
               <a:extLst>
                 <a:ext uri="{96DAC541-7B7A-43D3-8B79-37D633B846F1}">
-                  <asvg:svgBlip xmlns:asvg="http://schemas.microsoft.com/office/drawing/2016/SVG/main" r:embed="rId4"/>
+                  <asvg:svgBlip xmlns:asvg="http://schemas.microsoft.com/office/drawing/2016/SVG/main" r:embed="rId3"/>
                 </a:ext>
               </a:extLst>
             </a:blip>
@@ -4112,7 +4112,7 @@
                   <a:schemeClr val="bg1"/>
                 </a:solidFill>
               </a:rPr>
-              <a:t>CMSC 491/691: Interactive Fiction and Text Generation</a:t>
+              <a:t>CMSC 473/673: Introduction to Natural Language Processing</a:t>
             </a:r>
           </a:p>
           <a:p>
@@ -4122,7 +4122,7 @@
                   <a:schemeClr val="bg1"/>
                 </a:solidFill>
               </a:rPr>
-              <a:t>Fall 2025</a:t>
+              <a:t>Spring 2026</a:t>
             </a:r>
           </a:p>
         </p:txBody>

</xml_diff>